<commit_message>
fix(templates): correct BEST REGARDS section to 4-line format for LOR and Internship certificates
</commit_message>
<xml_diff>
--- a/test_5_internship.pptx
+++ b/test_5_internship.pptx
@@ -3120,6 +3120,10 @@
             </a:stretch>
           </a:blipFill>
         </p:spPr>
+        <p:txBody>
+          <a:bodyPr/>
+          <a:p/>
+        </p:txBody>
       </p:sp>
       <p:grpSp>
         <p:nvGrpSpPr>
@@ -4167,56 +4171,34 @@
               <a:lnSpc>
                 <a:spcPts val="1425"/>
               </a:lnSpc>
+              <a:defRPr/>
             </a:pPr>
             <a:r>
-              <a:rPr lang="en-US" sz="909">
-                <a:solidFill>
-                  <a:srgbClr val="000000"/>
-                </a:solidFill>
-                <a:latin typeface="Arial"/>
-                <a:ea typeface="Arial"/>
-                <a:cs typeface="Arial"/>
-                <a:sym typeface="Arial"/>
-              </a:rPr>
               <a:t>BEST REGARDS,</a:t>
             </a:r>
           </a:p>
           <a:p>
-            <a:pPr algn="l">
-              <a:lnSpc>
-                <a:spcPts val="1425"/>
-              </a:lnSpc>
+            <a:pPr>
+              <a:defRPr/>
             </a:pPr>
             <a:r>
-              <a:rPr lang="en-US" sz="909">
-                <a:solidFill>
-                  <a:srgbClr val="000000"/>
-                </a:solidFill>
-                <a:latin typeface="Arial"/>
-                <a:ea typeface="Arial"/>
-                <a:cs typeface="Arial"/>
-                <a:sym typeface="Arial"/>
-              </a:rPr>
-              <a:t>KARTHIKEYAN SUNDHARESAN, COPTER CODE, hr@coptercode.co.in</a:t>
-            </a:r>
-          </a:p>
-          <a:p>
-            <a:pPr algn="l">
-              <a:lnSpc>
-                <a:spcPts val="1425"/>
-              </a:lnSpc>
+              <a:t>KARTHIKEYAN SUNDHARESAN,</a:t>
+            </a:r>
+          </a:p>
+          <a:p>
+            <a:pPr>
+              <a:defRPr/>
             </a:pPr>
             <a:r>
-              <a:rPr lang="en-US" sz="909">
-                <a:solidFill>
-                  <a:srgbClr val="000000"/>
-                </a:solidFill>
-                <a:latin typeface="Arial"/>
-                <a:ea typeface="Arial"/>
-                <a:cs typeface="Arial"/>
-                <a:sym typeface="Arial"/>
-              </a:rPr>
-              <a:t>+91 96554 51382 www.Coptercode.co.in</a:t>
+              <a:t>HR TEAM HEAD,</a:t>
+            </a:r>
+          </a:p>
+          <a:p>
+            <a:pPr>
+              <a:defRPr/>
+            </a:pPr>
+            <a:r>
+              <a:t>COPTER CODE.</a:t>
             </a:r>
           </a:p>
         </p:txBody>

</xml_diff>